<commit_message>
docs: switch the project method to Kanban (slides, report, README, contributing guide)
</commit_message>
<xml_diff>
--- a/documentation/graduation-1/Smart Survey Platform - Graduation 1 - Seminar 1.pptx
+++ b/documentation/graduation-1/Smart Survey Platform - Graduation 1 - Seminar 1.pptx
@@ -218,7 +218,7 @@
           <a:p>
             <a:fld id="{5A2D380A-B25C-4554-9D12-6A864851EAA3}" type="datetimeFigureOut">
               <a:rPr lang="en-US" smtClean="0"/>
-              <a:t>10/28/2026</a:t>
+              <a:t>10/29/2026</a:t>
             </a:fld>
             <a:endParaRPr lang="en-US"/>
           </a:p>
@@ -600,7 +600,7 @@
           <a:lstStyle/>
           <a:p>
             <a:r>
-              <a:t>خمسة Sprints بعد Iteration 0، كل منها يبدأ بـ Design وينتهي بمراجعة مع المشرف. متطلبات Must في Sprint 1 و Sprint 2 لأنها الأعلى خطراً. التقرير يُكتب مع كل Sprint لا في النهاية. (60 ثانية)</a:t>
+              <a:t>هذه خطة متوقعة وليست التزاماً ثابتاً: بعد Iteration 0 أربعة Increments مدة كل منها أسبوعان، نسحب فيها البنود بترتيب الأولوية، ونعرض ما أُنجز على المشرفين في نهاية كل Increment. متطلبات Must في Increment 1 و Increment 2 لأنها الأعلى خطراً. التقرير يُكتب مع كل Increment لا في النهاية. (60 ثانية)</a:t>
             </a:r>
           </a:p>
         </p:txBody>
@@ -1023,7 +1023,7 @@
           <a:lstStyle/>
           <a:p>
             <a:r>
-              <a:t>V1.0 هو أساس العمل. في Iteration 0 بنينا Prototype معمارياً لتقليل خطر Flutter. عدد اختبارات الخادم: ضعوا الرقم الدقيق من آخر تشغيل في CI. (60 ثانية)</a:t>
+              <a:t>V1.0 هو أساس العمل. في Iteration 0 بنينا Prototype معمارياً لتقليل خطر Flutter. الرقم 163 هو عدد الاختبارات في تقرير المشروع الفصلي المسلَّم. (60 ثانية)</a:t>
             </a:r>
           </a:p>
         </p:txBody>
@@ -1373,7 +1373,7 @@
           <a:lstStyle/>
           <a:p>
             <a:r>
-              <a:t>تكراري (Iterative): نعيد ونحسّن بعد ملاحظات المشرف. تزايدي (Incremental): كل Sprint يضيف جزءاً يعمل. المخططات (Sequence، Activity، Class، ERD، State Machine) تُرسم في مرحلة Design من كل Sprint وتُوثق في التقرير وعلى GitHub. (75 ثانية)</a:t>
+              <a:t>اخترنا Kanban لأننا نعمل بنظام مختلط: جلسات مشتركة وأيام يعمل فيها كل واحد من منزله. Scrum الكامل يفترض Daily Scrum في كل يوم عمل وأدوار Product Owner و Scrum Master، وتطبيق جزء منه لا يُعدّ Scrum بحسب دليله. Kanban لا يفرض أدواراً ولا اجتماعات، ويلزمنا بثلاثة أشياء: سير عمل معرّف بأعمدته وسياساته، وحدود WIP (ثلاثة بنود قيد التنفيذ، بند لكل طالب، واثنان في المراجعة)، وأربعة مقاييس تدفق نحسبها من تواريخ GitHub. كل بند يمر بـ Ready ثم In Progress ثم Review ثم Done، ونرسم مخططاته (Agile Modeling) عند سحبه. كل أسبوعين نعرض ما أُنجز على المشرفين ونضع Release Tag. (75 ثانية)</a:t>
             </a:r>
           </a:p>
         </p:txBody>
@@ -1443,7 +1443,7 @@
           <a:lstStyle/>
           <a:p>
             <a:r>
-              <a:t>ثلاث Tiers فيزيائية (Client، Application، Data) وثلاث Layers منطقية داخل الخادم حسب Fowler: Presentation و Business و Data Access. Repository و Service Layer و Gateway أنماط تصميم داخل الطبقات، لا طبقات. نماذج Django تتبع Active Record فتستخدمها طبقتا Business و Data Access. تحقّقنا من الكود: الـ Views لا تستدعي Repositories ولا ORM مباشرة. Sentiment Analysis يجري بعد حفظ الإجابة (NFR-01). (75 ثانية)</a:t>
+              <a:t>ثلاث Tiers فيزيائية (Client، Application، Data) وثلاث Layers منطقية داخل الخادم حسب Fowler: Presentation و Business و Data Source. Repository و Service Layer و Gateway أنماط تصميم داخل الطبقات، لا طبقات. نماذج Django تتبع Active Record فتستخدمها طبقتا Business و Data Source. تحقّقنا من الكود: الـ Views لا تستدعي Repositories ولا ORM مباشرة. Sentiment Analysis يجري بعد حفظ الإجابة (NFR-01). (75 ثانية)</a:t>
             </a:r>
           </a:p>
         </p:txBody>
@@ -1508,7 +1508,7 @@
           <a:p>
             <a:fld id="{4E54A005-A4AE-48B5-9B72-AC59F9D0C9F3}" type="datetime1">
               <a:rPr lang="en-US" smtClean="0"/>
-              <a:t>10/28/2026</a:t>
+              <a:t>10/29/2026</a:t>
             </a:fld>
             <a:endParaRPr lang="en-US"/>
           </a:p>
@@ -1710,7 +1710,7 @@
           <a:p>
             <a:fld id="{07C97074-5979-461C-BB0D-F24AD7AEA7D7}" type="datetime1">
               <a:rPr lang="en-US" smtClean="0"/>
-              <a:t>10/28/2026</a:t>
+              <a:t>10/29/2026</a:t>
             </a:fld>
             <a:endParaRPr lang="en-US"/>
           </a:p>
@@ -1922,7 +1922,7 @@
           <a:p>
             <a:fld id="{CF7CA7B2-F8F1-4C99-9A58-0619E9B4236C}" type="datetime1">
               <a:rPr lang="en-US" smtClean="0"/>
-              <a:t>10/28/2026</a:t>
+              <a:t>10/29/2026</a:t>
             </a:fld>
             <a:endParaRPr lang="en-US"/>
           </a:p>
@@ -2124,7 +2124,7 @@
           <a:p>
             <a:fld id="{CF5F1D80-E922-4C56-BACD-EEFC21DCFF81}" type="datetime1">
               <a:rPr lang="en-US" smtClean="0"/>
-              <a:t>10/28/2026</a:t>
+              <a:t>10/29/2026</a:t>
             </a:fld>
             <a:endParaRPr lang="en-US"/>
           </a:p>
@@ -2403,7 +2403,7 @@
           <a:p>
             <a:fld id="{49343454-2FB9-4C8F-B182-7B2E5743343C}" type="datetime1">
               <a:rPr lang="en-US" smtClean="0"/>
-              <a:t>10/28/2026</a:t>
+              <a:t>10/29/2026</a:t>
             </a:fld>
             <a:endParaRPr lang="en-US"/>
           </a:p>
@@ -2672,7 +2672,7 @@
           <a:p>
             <a:fld id="{5D83650C-01B7-4756-A73F-6F4EA1E5431E}" type="datetime1">
               <a:rPr lang="en-US" smtClean="0"/>
-              <a:t>10/28/2026</a:t>
+              <a:t>10/29/2026</a:t>
             </a:fld>
             <a:endParaRPr lang="en-US"/>
           </a:p>
@@ -3088,7 +3088,7 @@
           <a:p>
             <a:fld id="{733A1D95-9BF9-4CE1-A0EA-90FF297D19D0}" type="datetime1">
               <a:rPr lang="en-US" smtClean="0"/>
-              <a:t>10/28/2026</a:t>
+              <a:t>10/29/2026</a:t>
             </a:fld>
             <a:endParaRPr lang="en-US"/>
           </a:p>
@@ -3233,7 +3233,7 @@
           <a:p>
             <a:fld id="{F9E80EBF-8A8A-40F0-86A7-7286F440E0F3}" type="datetime1">
               <a:rPr lang="en-US" smtClean="0"/>
-              <a:t>10/28/2026</a:t>
+              <a:t>10/29/2026</a:t>
             </a:fld>
             <a:endParaRPr lang="en-US"/>
           </a:p>
@@ -3350,7 +3350,7 @@
           <a:p>
             <a:fld id="{0BEA7337-48F7-4AF7-9A31-C231AA9DABEB}" type="datetime1">
               <a:rPr lang="en-US" smtClean="0"/>
-              <a:t>10/28/2026</a:t>
+              <a:t>10/29/2026</a:t>
             </a:fld>
             <a:endParaRPr lang="en-US"/>
           </a:p>
@@ -3665,7 +3665,7 @@
           <a:p>
             <a:fld id="{F9F60AB9-8616-4B55-B544-8181381708AB}" type="datetime1">
               <a:rPr lang="en-US" smtClean="0"/>
-              <a:t>10/28/2026</a:t>
+              <a:t>10/29/2026</a:t>
             </a:fld>
             <a:endParaRPr lang="en-US"/>
           </a:p>
@@ -3957,7 +3957,7 @@
           <a:p>
             <a:fld id="{E207D518-531C-4414-B657-2CD37CCA6B63}" type="datetime1">
               <a:rPr lang="en-US" smtClean="0"/>
-              <a:t>10/28/2026</a:t>
+              <a:t>10/29/2026</a:t>
             </a:fld>
             <a:endParaRPr lang="en-US"/>
           </a:p>
@@ -4202,7 +4202,7 @@
           <a:p>
             <a:fld id="{5359F99F-ECCB-4E1D-B4DE-BB12197DD00B}" type="datetime1">
               <a:rPr lang="en-US" smtClean="0"/>
-              <a:t>10/28/2026</a:t>
+              <a:t>10/29/2026</a:t>
             </a:fld>
             <a:endParaRPr lang="en-US"/>
           </a:p>
@@ -6753,7 +6753,7 @@
                 <a:ea typeface="Times New Roman"/>
                 <a:cs typeface="Times New Roman"/>
               </a:rPr>
-              <a:t>S0</a:t>
+              <a:t>I0</a:t>
             </a:r>
           </a:p>
         </p:txBody>
@@ -6818,7 +6818,7 @@
                 <a:ea typeface="Times New Roman"/>
                 <a:cs typeface="Times New Roman"/>
               </a:rPr>
-              <a:t>Sprint 1: FR-01, FR-02, FR-06, FR-08, FR-16</a:t>
+              <a:t>Increment 1: FR-01, FR-02, FR-06, FR-08, FR-16</a:t>
             </a:r>
           </a:p>
         </p:txBody>
@@ -6949,7 +6949,7 @@
                 <a:ea typeface="Times New Roman"/>
                 <a:cs typeface="Times New Roman"/>
               </a:rPr>
-              <a:t>S1</a:t>
+              <a:t>I1</a:t>
             </a:r>
           </a:p>
         </p:txBody>
@@ -7078,7 +7078,7 @@
                 <a:ea typeface="Times New Roman"/>
                 <a:cs typeface="Times New Roman"/>
               </a:rPr>
-              <a:t>Sprint 2: FR-03, FR-04, FR-07, FR-09 + Eval</a:t>
+              <a:t>Increment 2: FR-03, FR-04, FR-07, FR-09 + Eval</a:t>
             </a:r>
           </a:p>
         </p:txBody>
@@ -7209,7 +7209,7 @@
                 <a:ea typeface="Times New Roman"/>
                 <a:cs typeface="Times New Roman"/>
               </a:rPr>
-              <a:t>S2</a:t>
+              <a:t>I2</a:t>
             </a:r>
           </a:p>
         </p:txBody>
@@ -7338,7 +7338,7 @@
                 <a:ea typeface="Times New Roman"/>
                 <a:cs typeface="Times New Roman"/>
               </a:rPr>
-              <a:t>Sprint 3: FR-05, FR-10, FR-11, FR-12</a:t>
+              <a:t>Increment 3: FR-05, FR-10, FR-11, FR-12</a:t>
             </a:r>
           </a:p>
         </p:txBody>
@@ -7469,7 +7469,7 @@
                 <a:ea typeface="Times New Roman"/>
                 <a:cs typeface="Times New Roman"/>
               </a:rPr>
-              <a:t>S3</a:t>
+              <a:t>I3</a:t>
             </a:r>
           </a:p>
         </p:txBody>
@@ -7598,7 +7598,7 @@
                 <a:ea typeface="Times New Roman"/>
                 <a:cs typeface="Times New Roman"/>
               </a:rPr>
-              <a:t>Sprint 4: FR-13 – FR-15 + FR-17 – FR-20</a:t>
+              <a:t>Increment 4: FR-13 – FR-15 + FR-17 – FR-20</a:t>
             </a:r>
           </a:p>
         </p:txBody>
@@ -7729,7 +7729,7 @@
                 <a:ea typeface="Times New Roman"/>
                 <a:cs typeface="Times New Roman"/>
               </a:rPr>
-              <a:t>S4</a:t>
+              <a:t>I4</a:t>
             </a:r>
           </a:p>
         </p:txBody>
@@ -7858,7 +7858,7 @@
                 <a:ea typeface="Times New Roman"/>
                 <a:cs typeface="Times New Roman"/>
               </a:rPr>
-              <a:t>Release (S5): System &amp; Performance Tests</a:t>
+              <a:t>Release: System &amp; Performance Tests</a:t>
             </a:r>
           </a:p>
         </p:txBody>
@@ -7987,7 +7987,7 @@
                 <a:ea typeface="Times New Roman"/>
                 <a:cs typeface="Times New Roman"/>
               </a:rPr>
-              <a:t>Report Writing (every Sprint)</a:t>
+              <a:t>Report Writing (every Increment)</a:t>
             </a:r>
           </a:p>
         </p:txBody>
@@ -9333,7 +9333,7 @@
         </p:nvSpPr>
         <p:spPr>
           <a:xfrm>
-            <a:off x="548640" y="5879592"/>
+            <a:off x="586022" y="6027762"/>
             <a:ext cx="11091672" cy="256032"/>
           </a:xfrm>
           <a:prstGeom prst="rect">
@@ -9357,7 +9357,7 @@
               <a:buNone/>
             </a:pPr>
             <a:r>
-              <a:rPr lang="ar-SY" altLang="en-US" sz="1100" b="0" i="0" dirty="0">
+              <a:rPr lang="ar-SY" altLang="en-US" sz="1400" b="1" i="0" dirty="0">
                 <a:solidFill>
                   <a:srgbClr val="595959"/>
                 </a:solidFill>
@@ -9365,10 +9365,10 @@
                 <a:ea typeface="Times New Roman"/>
                 <a:cs typeface="Times New Roman"/>
               </a:rPr>
-              <a:t>الزمن يتقدم من اليمين إلى اليسار، والخطوط الرمادية تفصل الأسابيع. كل</a:t>
-            </a:r>
-            <a:r>
-              <a:rPr lang="en-US" altLang="en-US" sz="1100" b="0" i="0" dirty="0">
+              <a:t>الزمن يتقدم من اليمين إلى اليسار، والخطوط الرمادية تفصل الأسابيع. كل </a:t>
+            </a:r>
+            <a:r>
+              <a:rPr lang="en-US" altLang="en-US" sz="1400" b="1" i="0" dirty="0">
                 <a:solidFill>
                   <a:srgbClr val="595959"/>
                 </a:solidFill>
@@ -9376,10 +9376,10 @@
                 <a:ea typeface="Times New Roman"/>
                 <a:cs typeface="Times New Roman"/>
               </a:rPr>
-              <a:t> Sprint </a:t>
-            </a:r>
-            <a:r>
-              <a:rPr lang="ar-SY" altLang="en-US" sz="1100" b="0" i="0" dirty="0">
+              <a:t> Increment </a:t>
+            </a:r>
+            <a:r>
+              <a:rPr lang="ar-SY" altLang="en-US" sz="1400" b="1" i="0" dirty="0">
                 <a:solidFill>
                   <a:srgbClr val="595959"/>
                 </a:solidFill>
@@ -9387,73 +9387,7 @@
                 <a:ea typeface="Times New Roman"/>
                 <a:cs typeface="Times New Roman"/>
               </a:rPr>
-              <a:t>أسبوعان</a:t>
-            </a:r>
-            <a:r>
-              <a:rPr lang="en-US" altLang="en-US" sz="1100" b="0" i="0" dirty="0">
-                <a:solidFill>
-                  <a:srgbClr val="595959"/>
-                </a:solidFill>
-                <a:latin typeface="Times New Roman"/>
-                <a:ea typeface="Times New Roman"/>
-                <a:cs typeface="Times New Roman"/>
-              </a:rPr>
-              <a:t>: Design </a:t>
-            </a:r>
-            <a:r>
-              <a:rPr lang="ar-SY" altLang="en-US" sz="1100" b="0" i="0" dirty="0">
-                <a:solidFill>
-                  <a:srgbClr val="595959"/>
-                </a:solidFill>
-                <a:latin typeface="Times New Roman"/>
-                <a:ea typeface="Times New Roman"/>
-                <a:cs typeface="Times New Roman"/>
-              </a:rPr>
-              <a:t>ثم</a:t>
-            </a:r>
-            <a:r>
-              <a:rPr lang="en-US" altLang="en-US" sz="1100" b="0" i="0" dirty="0">
-                <a:solidFill>
-                  <a:srgbClr val="595959"/>
-                </a:solidFill>
-                <a:latin typeface="Times New Roman"/>
-                <a:ea typeface="Times New Roman"/>
-                <a:cs typeface="Times New Roman"/>
-              </a:rPr>
-              <a:t> Implementation </a:t>
-            </a:r>
-            <a:r>
-              <a:rPr lang="ar-SY" altLang="en-US" sz="1100" b="0" i="0" dirty="0">
-                <a:solidFill>
-                  <a:srgbClr val="595959"/>
-                </a:solidFill>
-                <a:latin typeface="Times New Roman"/>
-                <a:ea typeface="Times New Roman"/>
-                <a:cs typeface="Times New Roman"/>
-              </a:rPr>
-              <a:t>ثم</a:t>
-            </a:r>
-            <a:r>
-              <a:rPr lang="en-US" altLang="en-US" sz="1100" b="0" i="0" dirty="0">
-                <a:solidFill>
-                  <a:srgbClr val="595959"/>
-                </a:solidFill>
-                <a:latin typeface="Times New Roman"/>
-                <a:ea typeface="Times New Roman"/>
-                <a:cs typeface="Times New Roman"/>
-              </a:rPr>
-              <a:t> Testing &amp; Review </a:t>
-            </a:r>
-            <a:r>
-              <a:rPr lang="ar-SY" altLang="en-US" sz="1100" b="0" i="0" dirty="0">
-                <a:solidFill>
-                  <a:srgbClr val="595959"/>
-                </a:solidFill>
-                <a:latin typeface="Times New Roman"/>
-                <a:ea typeface="Times New Roman"/>
-                <a:cs typeface="Times New Roman"/>
-              </a:rPr>
-              <a:t>مع المشرف.</a:t>
+              <a:t>أسبوعان وينتهي بمراجعة مع المشرفين.</a:t>
             </a:r>
           </a:p>
         </p:txBody>
@@ -10045,19 +9979,18 @@
                 <a:ea typeface="Times New Roman"/>
                 <a:cs typeface="Times New Roman"/>
               </a:rPr>
-              <a:t>[10]</a:t>
-            </a:r>
-            <a:r>
-              <a:rPr lang="en-US" sz="1100" dirty="0"/>
-              <a:t> S. Westwood, "The potential existential threat of large language models to online survey research," Proc. Natl. Acad. Sci. U.S.A., 2025, </a:t>
-            </a:r>
-            <a:r>
-              <a:rPr lang="en-US" sz="1100" dirty="0" err="1"/>
-              <a:t>doi</a:t>
-            </a:r>
-            <a:r>
-              <a:rPr lang="en-US" sz="1100" dirty="0"/>
-              <a:t>: 10.1073/pnas.2518075122.</a:t>
+              <a:t>[10] </a:t>
+            </a:r>
+            <a:r>
+              <a:rPr lang="en-US" altLang="en-US" sz="1100" b="0" i="0" dirty="0">
+                <a:solidFill>
+                  <a:srgbClr val="1A1A1A"/>
+                </a:solidFill>
+                <a:latin typeface="Times New Roman"/>
+                <a:ea typeface="Times New Roman"/>
+                <a:cs typeface="Times New Roman"/>
+              </a:rPr>
+              <a:t>S. Westwood, "The potential existential threat of large language models to online survey research," Proc. Natl. Acad. Sci. U.S.A., 2025, doi: 10.1073/pnas.2518075122.</a:t>
             </a:r>
           </a:p>
           <a:p>
@@ -10115,16 +10048,15 @@
               <a:t>[12] </a:t>
             </a:r>
             <a:r>
-              <a:rPr lang="en-US" sz="1100" dirty="0"/>
-              <a:t>M. T. I. Khondaker, A. Waheed, E. M. B. Nagoudi, and M. Abdul-</a:t>
-            </a:r>
-            <a:r>
-              <a:rPr lang="en-US" sz="1100" dirty="0" err="1"/>
-              <a:t>Mageed</a:t>
-            </a:r>
-            <a:r>
-              <a:rPr lang="en-US" sz="1100" dirty="0"/>
-              <a:t>, "GPTAraEval: A comprehensive evaluation of ChatGPT on Arabic NLP," in Proc. EMNLP, 2023, pp. 220–247.</a:t>
+              <a:rPr lang="en-US" altLang="en-US" sz="1100" b="0" i="0" dirty="0">
+                <a:solidFill>
+                  <a:srgbClr val="1A1A1A"/>
+                </a:solidFill>
+                <a:latin typeface="Times New Roman"/>
+                <a:ea typeface="Times New Roman"/>
+                <a:cs typeface="Times New Roman"/>
+              </a:rPr>
+              <a:t>M. T. I. Khondaker, A. Waheed, E. M. B. Nagoudi, and M. Abdul-Mageed, "GPTAraEval: A comprehensive evaluation of ChatGPT on Arabic NLP," in Proc. EMNLP, 2023, pp. 220–247.</a:t>
             </a:r>
           </a:p>
           <a:p>
@@ -10411,7 +10343,7 @@
                 <a:ea typeface="Times New Roman"/>
                 <a:cs typeface="Times New Roman"/>
               </a:rPr>
-              <a:t>K. Schwaber and J. Sutherland, The Scrum Guide, 2020. [Online]. Available: scrumguides.org</a:t>
+              <a:t>J. Coleman and D. S. Vacanti, The Kanban Guide, May 2025. [Online]. Available: kanbanguides.org</a:t>
             </a:r>
           </a:p>
           <a:p>
@@ -10510,7 +10442,7 @@
                 <a:ea typeface="Times New Roman"/>
                 <a:cs typeface="Times New Roman"/>
               </a:rPr>
-              <a:t>M. Fowler, Patterns of Enterprise Application Architecture. Addison-Wesley, 2002.</a:t>
+              <a:t>J. Saltz, R. Heckman, and I. Shamshurin, "Exploring how different project management methodologies impact data science students," in Proc. 25th Eur. Conf. Inf. Syst. (ECIS), 2017, pp. 2939–2948.</a:t>
             </a:r>
           </a:p>
           <a:p>
@@ -10543,7 +10475,7 @@
                 <a:ea typeface="Times New Roman"/>
                 <a:cs typeface="Times New Roman"/>
               </a:rPr>
-              <a:t>R. T. Fielding, "Architectural styles and the design of network-based software architectures," Ph.D. dissertation, Univ. of California, Irvine, 2000.</a:t>
+              <a:t>M. Fowler, Patterns of Enterprise Application Architecture. Addison-Wesley, 2002.</a:t>
             </a:r>
           </a:p>
           <a:p>
@@ -10566,6 +10498,39 @@
                 <a:cs typeface="Times New Roman"/>
               </a:rPr>
               <a:t>[25] </a:t>
+            </a:r>
+            <a:r>
+              <a:rPr lang="en-US" altLang="en-US" sz="1100" b="0" i="0" dirty="0">
+                <a:solidFill>
+                  <a:srgbClr val="1A1A1A"/>
+                </a:solidFill>
+                <a:latin typeface="Times New Roman"/>
+                <a:ea typeface="Times New Roman"/>
+                <a:cs typeface="Times New Roman"/>
+              </a:rPr>
+              <a:t>R. T. Fielding, "Architectural styles and the design of network-based software architectures," Ph.D. dissertation, Univ. of California, Irvine, 2000.</a:t>
+            </a:r>
+          </a:p>
+          <a:p>
+            <a:pPr algn="l" rtl="0">
+              <a:spcBef>
+                <a:spcPts val="0"/>
+              </a:spcBef>
+              <a:spcAft>
+                <a:spcPts val="300"/>
+              </a:spcAft>
+              <a:buNone/>
+            </a:pPr>
+            <a:r>
+              <a:rPr lang="en-US" altLang="en-US" sz="1100" b="1" i="0" dirty="0">
+                <a:solidFill>
+                  <a:srgbClr val="2F5496"/>
+                </a:solidFill>
+                <a:latin typeface="Times New Roman"/>
+                <a:ea typeface="Times New Roman"/>
+                <a:cs typeface="Times New Roman"/>
+              </a:rPr>
+              <a:t>[26] </a:t>
             </a:r>
             <a:r>
               <a:rPr lang="en-US" altLang="en-US" sz="1100" b="0" i="0" dirty="0">
@@ -11712,7 +11677,7 @@
                 <a:ea typeface="Times New Roman"/>
                 <a:cs typeface="Times New Roman"/>
               </a:rPr>
-              <a:t>بناء منصة استبيانات توصل كل استبيان إلى المستجيبين المناسبين، وتكشف الإجابات منخفضة الجودة، وتحلل مشاعر الإجابات المفتوحة — بنهاية تخرج</a:t>
+              <a:t>بناء منصة استبيانات توصل كل استبيان إلى المستجيبين المناسبين، وتكشف الإجابات منخفضة الجودة، وتحلل مشاعر الإجابات المفتوحة — بنهاية تخرج </a:t>
             </a:r>
             <a:r>
               <a:rPr lang="en-US" altLang="en-US" sz="1600" b="0" i="0" dirty="0">
@@ -11723,7 +11688,7 @@
                 <a:ea typeface="Times New Roman"/>
                 <a:cs typeface="Times New Roman"/>
               </a:rPr>
-              <a:t> 1 )</a:t>
+              <a:t>1 )</a:t>
             </a:r>
             <a:r>
               <a:rPr lang="ar-SY" altLang="en-US" sz="1600" b="0" i="0" dirty="0">
@@ -11745,18 +11710,7 @@
                 <a:ea typeface="Times New Roman"/>
                 <a:cs typeface="Times New Roman"/>
               </a:rPr>
-              <a:t> 2027 </a:t>
-            </a:r>
-            <a:r>
-              <a:rPr lang="en-US" altLang="en-US" sz="1600" dirty="0">
-                <a:solidFill>
-                  <a:srgbClr val="FFFFFF"/>
-                </a:solidFill>
-                <a:latin typeface="Times New Roman"/>
-                <a:ea typeface="Times New Roman"/>
-                <a:cs typeface="Times New Roman"/>
-              </a:rPr>
-              <a:t>(</a:t>
+              <a:t>2027 (</a:t>
             </a:r>
             <a:endParaRPr lang="ar-SY" altLang="en-US" sz="1600" b="0" i="0" dirty="0">
               <a:solidFill>
@@ -25000,7 +24954,7 @@
                 <a:ea typeface="Times New Roman"/>
                 <a:cs typeface="Times New Roman"/>
               </a:rPr>
-              <a:t>المتطلبات الوظيفية لمشروع تخرج</a:t>
+              <a:t>المتطلبات الوظيفية لمشروع تخرج </a:t>
             </a:r>
             <a:r>
               <a:rPr lang="en-US" altLang="en-US" sz="2800" b="1" i="0" dirty="0">
@@ -25011,7 +24965,7 @@
                 <a:ea typeface="Times New Roman"/>
                 <a:cs typeface="Times New Roman"/>
               </a:rPr>
-              <a:t> (FR-01 – FR-20) 1</a:t>
+              <a:t>1 (FR-01 – FR-20)</a:t>
             </a:r>
             <a:endParaRPr lang="ar-SY" altLang="en-US" sz="2800" b="1" i="0" dirty="0">
               <a:solidFill>
@@ -25030,7 +24984,13 @@
           <p:cNvGraphicFramePr>
             <a:graphicFrameLocks noGrp="1"/>
           </p:cNvGraphicFramePr>
-          <p:nvPr/>
+          <p:nvPr>
+            <p:extLst>
+              <p:ext uri="{D42A27DB-BD31-4B8C-83A1-F6EECF244321}">
+                <p14:modId xmlns:p14="http://schemas.microsoft.com/office/powerpoint/2010/main" val="3355608667"/>
+              </p:ext>
+            </p:extLst>
+          </p:nvPr>
         </p:nvGraphicFramePr>
         <p:xfrm>
           <a:off x="6355080" y="932688"/>
@@ -26250,7 +26210,29 @@
                           <a:ea typeface="Times New Roman"/>
                           <a:cs typeface="Times New Roman"/>
                         </a:rPr>
-                        <a:t>تحليل مشاعر الإجابات المفتوحة (فصحى، إنجليزي) ★</a:t>
+                        <a:t>تحليل مشاعر الإجابات المفتوحة (</a:t>
+                      </a:r>
+                      <a:r>
+                        <a:rPr lang="ar-SA" altLang="en-US" sz="1400" b="0" i="0" dirty="0">
+                          <a:solidFill>
+                            <a:srgbClr val="1A1A1A"/>
+                          </a:solidFill>
+                          <a:latin typeface="Times New Roman"/>
+                          <a:ea typeface="Times New Roman"/>
+                          <a:cs typeface="Times New Roman"/>
+                        </a:rPr>
+                        <a:t>عربي </a:t>
+                      </a:r>
+                      <a:r>
+                        <a:rPr lang="ar-SY" altLang="en-US" sz="1400" b="0" i="0" dirty="0">
+                          <a:solidFill>
+                            <a:srgbClr val="1A1A1A"/>
+                          </a:solidFill>
+                          <a:latin typeface="Times New Roman"/>
+                          <a:ea typeface="Times New Roman"/>
+                          <a:cs typeface="Times New Roman"/>
+                        </a:rPr>
+                        <a:t>فصحى، إنجليزي) ★</a:t>
                       </a:r>
                     </a:p>
                   </a:txBody>
@@ -27272,6 +27254,17 @@
                         <a:t>رابط دعوة فريد مع نسخ سريع ورمز</a:t>
                       </a:r>
                       <a:r>
+                        <a:rPr lang="ar-SA" altLang="en-US" sz="1400" b="0" i="0" dirty="0">
+                          <a:solidFill>
+                            <a:srgbClr val="1A1A1A"/>
+                          </a:solidFill>
+                          <a:latin typeface="Times New Roman"/>
+                          <a:ea typeface="Times New Roman"/>
+                          <a:cs typeface="Times New Roman"/>
+                        </a:rPr>
+                        <a:t> </a:t>
+                      </a:r>
+                      <a:r>
                         <a:rPr lang="en-US" altLang="en-US" sz="1400" b="0" i="0" dirty="0">
                           <a:solidFill>
                             <a:srgbClr val="1A1A1A"/>
@@ -27341,7 +27334,7 @@
           <p:nvPr>
             <p:extLst>
               <p:ext uri="{D42A27DB-BD31-4B8C-83A1-F6EECF244321}">
-                <p14:modId xmlns:p14="http://schemas.microsoft.com/office/powerpoint/2010/main" val="2960715295"/>
+                <p14:modId xmlns:p14="http://schemas.microsoft.com/office/powerpoint/2010/main" val="223109059"/>
               </p:ext>
             </p:extLst>
           </p:nvPr>
@@ -29216,7 +29209,7 @@
                           <a:ea typeface="Times New Roman"/>
                           <a:cs typeface="Times New Roman"/>
                         </a:rPr>
-                        <a:t> (Completion / Drop-off)</a:t>
+                        <a:t> (Completion / Drop-off) </a:t>
                       </a:r>
                       <a:endParaRPr lang="ar-SY" altLang="en-US" sz="1400" b="0" i="0" dirty="0">
                         <a:solidFill>
@@ -30046,7 +30039,7 @@
               <a:t> (</a:t>
             </a:r>
             <a:r>
-              <a:rPr lang="en-AE" altLang="en-US" sz="1600" b="1" dirty="0">
+              <a:rPr lang="en-US" altLang="en-US" sz="1600" b="1" dirty="0">
                 <a:solidFill>
                   <a:srgbClr val="595959"/>
                 </a:solidFill>
@@ -30054,7 +30047,7 @@
                 <a:ea typeface="Times New Roman"/>
                 <a:cs typeface="Times New Roman"/>
               </a:rPr>
-              <a:t>won`t</a:t>
+              <a:t>Won't</a:t>
             </a:r>
             <a:r>
               <a:rPr lang="ar-SY" altLang="en-US" sz="1600" b="1" dirty="0">
@@ -30447,7 +30440,7 @@
                 <a:ea typeface="Times New Roman"/>
                 <a:cs typeface="Times New Roman"/>
               </a:rPr>
-              <a:t>منهجية التطوير ومراحل التنفيذ</a:t>
+              <a:t>منهجية التطوير ومراحل التنفيذ </a:t>
             </a:r>
             <a:r>
               <a:rPr lang="en-US" altLang="en-US" sz="2800" b="1" i="0" dirty="0">
@@ -30458,7 +30451,7 @@
                 <a:ea typeface="Times New Roman"/>
                 <a:cs typeface="Times New Roman"/>
               </a:rPr>
-              <a:t> (Scrum + Agile Modeling)</a:t>
+              <a:t>(Kanban + Agile Modeling)</a:t>
             </a:r>
             <a:endParaRPr lang="ar-SY" altLang="en-US" sz="2800" b="1" i="0" dirty="0">
               <a:solidFill>
@@ -30535,7 +30528,18 @@
                 <a:ea typeface="Times New Roman"/>
                 <a:cs typeface="Times New Roman"/>
               </a:rPr>
-              <a:t> Scrum </a:t>
+              <a:t>Kanban </a:t>
+            </a:r>
+            <a:r>
+              <a:rPr lang="ar-SA" altLang="en-US" sz="1600" b="1" i="0" dirty="0">
+                <a:solidFill>
+                  <a:srgbClr val="2F5496"/>
+                </a:solidFill>
+                <a:latin typeface="Times New Roman"/>
+                <a:ea typeface="Times New Roman"/>
+                <a:cs typeface="Times New Roman"/>
+              </a:rPr>
+              <a:t> </a:t>
             </a:r>
             <a:r>
               <a:rPr lang="ar-SY" altLang="en-US" sz="1600" b="1" i="0" dirty="0">
@@ -30546,7 +30550,18 @@
                 <a:ea typeface="Times New Roman"/>
                 <a:cs typeface="Times New Roman"/>
               </a:rPr>
-              <a:t>بـ</a:t>
+              <a:t>لإدارة سير العمل </a:t>
+            </a:r>
+            <a:r>
+              <a:rPr lang="en-US" altLang="en-US" sz="1600" b="1" dirty="0">
+                <a:solidFill>
+                  <a:srgbClr val="2F5496"/>
+                </a:solidFill>
+                <a:latin typeface="Times New Roman"/>
+                <a:ea typeface="Times New Roman"/>
+                <a:cs typeface="Times New Roman"/>
+              </a:rPr>
+              <a:t> </a:t>
             </a:r>
             <a:r>
               <a:rPr lang="en-US" altLang="en-US" sz="1600" b="1" i="0" dirty="0">
@@ -30557,7 +30572,7 @@
                 <a:ea typeface="Times New Roman"/>
                 <a:cs typeface="Times New Roman"/>
               </a:rPr>
-              <a:t> Sprints </a:t>
+              <a:t>+ </a:t>
             </a:r>
             <a:r>
               <a:rPr lang="ar-SY" altLang="en-US" sz="1600" b="1" i="0" dirty="0">
@@ -30568,7 +30583,7 @@
                 <a:ea typeface="Times New Roman"/>
                 <a:cs typeface="Times New Roman"/>
               </a:rPr>
-              <a:t>مدة كل منها أسبوعان + ممارسات</a:t>
+              <a:t>ممارسات </a:t>
             </a:r>
             <a:r>
               <a:rPr lang="en-US" altLang="en-US" sz="1600" b="1" i="0" dirty="0">
@@ -30590,7 +30605,35 @@
                 <a:ea typeface="Times New Roman"/>
                 <a:cs typeface="Times New Roman"/>
               </a:rPr>
-              <a:t>للتصميم: </a:t>
+              <a:t>للتصميم</a:t>
+            </a:r>
+            <a:r>
+              <a:rPr lang="en-US" altLang="en-US" sz="1600" b="1" i="0" dirty="0">
+                <a:solidFill>
+                  <a:srgbClr val="2F5496"/>
+                </a:solidFill>
+                <a:latin typeface="Times New Roman"/>
+                <a:ea typeface="Times New Roman"/>
+                <a:cs typeface="Times New Roman"/>
+              </a:rPr>
+              <a:t>:</a:t>
+            </a:r>
+            <a:r>
+              <a:rPr kumimoji="0" lang="en-US" altLang="en-US" sz="1100" b="0" i="0" u="none" strike="noStrike" kern="1200" cap="none" spc="0" normalizeH="0" baseline="0" noProof="0" dirty="0">
+                <a:ln>
+                  <a:noFill/>
+                </a:ln>
+                <a:solidFill>
+                  <a:srgbClr val="1A1A1A"/>
+                </a:solidFill>
+                <a:effectLst/>
+                <a:uLnTx/>
+                <a:uFillTx/>
+                <a:latin typeface="Times New Roman"/>
+                <a:ea typeface="Times New Roman"/>
+                <a:cs typeface="Times New Roman"/>
+              </a:rPr>
+              <a:t> [20][21][22] </a:t>
             </a:r>
             <a:r>
               <a:rPr lang="en-US" altLang="en-US" sz="1600" b="0" i="0" dirty="0">
@@ -30601,7 +30644,29 @@
                 <a:ea typeface="Times New Roman"/>
                 <a:cs typeface="Times New Roman"/>
               </a:rPr>
-              <a:t>Iterative &amp; Incremental Development [20][21][22]</a:t>
+              <a:t>Iterative &amp; Incremental Development </a:t>
+            </a:r>
+            <a:r>
+              <a:rPr lang="en-US" altLang="en-US" sz="1100" b="0" i="0" dirty="0">
+                <a:solidFill>
+                  <a:srgbClr val="1A1A1A"/>
+                </a:solidFill>
+                <a:latin typeface="Times New Roman"/>
+                <a:ea typeface="Times New Roman"/>
+                <a:cs typeface="Times New Roman"/>
+              </a:rPr>
+              <a:t> </a:t>
+            </a:r>
+            <a:r>
+              <a:rPr lang="en-US" altLang="en-US" sz="1600" b="0" i="0" dirty="0">
+                <a:solidFill>
+                  <a:srgbClr val="1A1A1A"/>
+                </a:solidFill>
+                <a:latin typeface="Times New Roman"/>
+                <a:ea typeface="Times New Roman"/>
+                <a:cs typeface="Times New Roman"/>
+              </a:rPr>
+              <a:t>‎</a:t>
             </a:r>
             <a:endParaRPr lang="ar-SY" altLang="en-US" sz="1600" b="0" i="0" dirty="0">
               <a:solidFill>
@@ -30642,7 +30707,7 @@
                 <a:ea typeface="Times New Roman"/>
                 <a:cs typeface="Times New Roman"/>
               </a:rPr>
-              <a:t>المتطلبات تغيّرت ثلاث مرات بملاحظات المشرف</a:t>
+              <a:t>نعمل معاً ومن المنازل؛ </a:t>
             </a:r>
             <a:r>
               <a:rPr lang="en-US" altLang="en-US" sz="1400" b="0" i="0" dirty="0">
@@ -30653,7 +30718,7 @@
                 <a:ea typeface="Times New Roman"/>
                 <a:cs typeface="Times New Roman"/>
               </a:rPr>
-              <a:t> Flutter) </a:t>
+              <a:t> Kanban </a:t>
             </a:r>
             <a:r>
               <a:rPr lang="ar-SY" altLang="en-US" sz="1400" b="0" i="0" dirty="0">
@@ -30664,7 +30729,7 @@
                 <a:ea typeface="Times New Roman"/>
                 <a:cs typeface="Times New Roman"/>
               </a:rPr>
-              <a:t>، اللغات، المنصات)، والمواعيد الجامعية ثابتة، فنسلّم</a:t>
+              <a:t>لا يفرض </a:t>
             </a:r>
             <a:r>
               <a:rPr lang="en-US" altLang="en-US" sz="1400" b="0" i="0" dirty="0">
@@ -30675,7 +30740,7 @@
                 <a:ea typeface="Times New Roman"/>
                 <a:cs typeface="Times New Roman"/>
               </a:rPr>
-              <a:t> Increment </a:t>
+              <a:t> Daily Scrum </a:t>
             </a:r>
             <a:r>
               <a:rPr lang="ar-SY" altLang="en-US" sz="1400" b="0" i="0" dirty="0">
@@ -30686,8 +30751,71 @@
                 <a:ea typeface="Times New Roman"/>
                 <a:cs typeface="Times New Roman"/>
               </a:rPr>
-              <a:t>يعمل كل أسبوعين ونراجعه مع المشرف.</a:t>
-            </a:r>
+              <a:t>ولا أدواراً، بل سير عمل معرّفاً وحدود </a:t>
+            </a:r>
+            <a:r>
+              <a:rPr lang="en-US" altLang="en-US" sz="1400" b="0" i="0" dirty="0">
+                <a:solidFill>
+                  <a:srgbClr val="1A1A1A"/>
+                </a:solidFill>
+                <a:latin typeface="Times New Roman"/>
+                <a:ea typeface="Times New Roman"/>
+                <a:cs typeface="Times New Roman"/>
+              </a:rPr>
+              <a:t> WIP </a:t>
+            </a:r>
+            <a:r>
+              <a:rPr lang="ar-SY" altLang="en-US" sz="1400" b="0" i="0" dirty="0">
+                <a:solidFill>
+                  <a:srgbClr val="1A1A1A"/>
+                </a:solidFill>
+                <a:latin typeface="Times New Roman"/>
+                <a:ea typeface="Times New Roman"/>
+                <a:cs typeface="Times New Roman"/>
+              </a:rPr>
+              <a:t>ومقاييس تدفق، وتفوّق على </a:t>
+            </a:r>
+            <a:r>
+              <a:rPr lang="en-US" altLang="en-US" sz="1400" b="0" i="0" dirty="0">
+                <a:solidFill>
+                  <a:srgbClr val="1A1A1A"/>
+                </a:solidFill>
+                <a:latin typeface="Times New Roman"/>
+                <a:ea typeface="Times New Roman"/>
+                <a:cs typeface="Times New Roman"/>
+              </a:rPr>
+              <a:t> Scrum </a:t>
+            </a:r>
+            <a:r>
+              <a:rPr lang="ar-SY" altLang="en-US" sz="1400" b="0" i="0" dirty="0">
+                <a:solidFill>
+                  <a:srgbClr val="1A1A1A"/>
+                </a:solidFill>
+                <a:latin typeface="Times New Roman"/>
+                <a:ea typeface="Times New Roman"/>
+                <a:cs typeface="Times New Roman"/>
+              </a:rPr>
+              <a:t>في تجربة على مشاريع طلابية </a:t>
+            </a:r>
+            <a:r>
+              <a:rPr lang="en-US" altLang="en-US" sz="1100" b="0" i="0" dirty="0">
+                <a:solidFill>
+                  <a:srgbClr val="1A1A1A"/>
+                </a:solidFill>
+                <a:latin typeface="Times New Roman"/>
+                <a:ea typeface="Times New Roman"/>
+                <a:cs typeface="Times New Roman"/>
+              </a:rPr>
+              <a:t>[23].</a:t>
+            </a:r>
+            <a:endParaRPr lang="en-US" altLang="en-US" sz="1400" b="0" i="0" dirty="0">
+              <a:solidFill>
+                <a:srgbClr val="1A1A1A"/>
+              </a:solidFill>
+              <a:latin typeface="Times New Roman"/>
+              <a:ea typeface="Times New Roman"/>
+              <a:cs typeface="Times New Roman"/>
+            </a:endParaRPr>
           </a:p>
         </p:txBody>
       </p:sp>
@@ -30751,7 +30879,7 @@
                 <a:ea typeface="Times New Roman"/>
                 <a:cs typeface="Times New Roman"/>
               </a:rPr>
-              <a:t>Iteration 0 (S0)</a:t>
+              <a:t>Iteration 0</a:t>
             </a:r>
             <a:endParaRPr lang="ar-SY" altLang="en-US" sz="1500" b="1" i="0" dirty="0">
               <a:solidFill>
@@ -30818,7 +30946,7 @@
               <a:buNone/>
             </a:pPr>
             <a:r>
-              <a:rPr lang="en-US" altLang="en-US" sz="1200" b="1" i="0" dirty="0">
+              <a:rPr lang="en-US" altLang="en-US" sz="1300" b="1" i="0" dirty="0">
                 <a:solidFill>
                   <a:srgbClr val="595959"/>
                 </a:solidFill>
@@ -30844,7 +30972,7 @@
               <a:buChar char="■"/>
             </a:pPr>
             <a:r>
-              <a:rPr lang="en-US" altLang="en-US" sz="1200" b="0" i="0" dirty="0">
+              <a:rPr lang="en-US" altLang="en-US" sz="1300" b="0" i="0" dirty="0">
                 <a:solidFill>
                   <a:srgbClr val="1A1A1A"/>
                 </a:solidFill>
@@ -30870,7 +30998,7 @@
               <a:buChar char="■"/>
             </a:pPr>
             <a:r>
-              <a:rPr lang="en-US" altLang="en-US" sz="1200" b="0" i="0" dirty="0">
+              <a:rPr lang="en-US" altLang="en-US" sz="1300" b="0" i="0" dirty="0">
                 <a:solidFill>
                   <a:srgbClr val="1A1A1A"/>
                 </a:solidFill>
@@ -30896,7 +31024,7 @@
               <a:buChar char="■"/>
             </a:pPr>
             <a:r>
-              <a:rPr lang="en-US" altLang="en-US" sz="1200" b="0" i="0" dirty="0">
+              <a:rPr lang="en-US" altLang="en-US" sz="1300" b="0" i="0" dirty="0">
                 <a:solidFill>
                   <a:srgbClr val="1A1A1A"/>
                 </a:solidFill>
@@ -30922,7 +31050,7 @@
               <a:buChar char="■"/>
             </a:pPr>
             <a:r>
-              <a:rPr lang="en-US" altLang="en-US" sz="1200" b="0" i="0" dirty="0">
+              <a:rPr lang="en-US" altLang="en-US" sz="1300" b="0" i="0" dirty="0">
                 <a:solidFill>
                   <a:srgbClr val="1A1A1A"/>
                 </a:solidFill>
@@ -30948,7 +31076,7 @@
               <a:buChar char="■"/>
             </a:pPr>
             <a:r>
-              <a:rPr lang="en-US" altLang="en-US" sz="1200" b="0" i="0" dirty="0">
+              <a:rPr lang="en-US" altLang="en-US" sz="1300" b="0" i="0" dirty="0">
                 <a:solidFill>
                   <a:srgbClr val="1A1A1A"/>
                 </a:solidFill>
@@ -30974,7 +31102,7 @@
               <a:buChar char="■"/>
             </a:pPr>
             <a:r>
-              <a:rPr lang="en-US" altLang="en-US" sz="1200" b="0" i="0" dirty="0">
+              <a:rPr lang="en-US" altLang="en-US" sz="1300" b="0" i="0" dirty="0">
                 <a:solidFill>
                   <a:srgbClr val="1A1A1A"/>
                 </a:solidFill>
@@ -30982,7 +31110,7 @@
                 <a:ea typeface="Times New Roman"/>
                 <a:cs typeface="Times New Roman"/>
               </a:rPr>
-              <a:t>Product Backlog: 23 Issues on GitHub Projects</a:t>
+              <a:t>Product Backlog: 25 Issues on GitHub Projects</a:t>
             </a:r>
           </a:p>
         </p:txBody>
@@ -31047,7 +31175,7 @@
                 <a:ea typeface="Times New Roman"/>
                 <a:cs typeface="Times New Roman"/>
               </a:rPr>
-              <a:t>1  Sprint Planning</a:t>
+              <a:t>1  Backlog → Ready</a:t>
             </a:r>
           </a:p>
         </p:txBody>
@@ -31118,7 +31246,7 @@
                 <a:ea typeface="Times New Roman"/>
                 <a:cs typeface="Times New Roman"/>
               </a:rPr>
-              <a:t>User Stories + Acceptance Criteria</a:t>
+              <a:t>User Story + Acceptance Criteria</a:t>
             </a:r>
           </a:p>
           <a:p>
@@ -31144,7 +31272,7 @@
                 <a:ea typeface="Times New Roman"/>
                 <a:cs typeface="Times New Roman"/>
               </a:rPr>
-              <a:t>Sprint Backlog</a:t>
+              <a:t>MoSCoW order: Must, Should, Could</a:t>
             </a:r>
           </a:p>
           <a:p>
@@ -31170,7 +31298,7 @@
                 <a:ea typeface="Times New Roman"/>
                 <a:cs typeface="Times New Roman"/>
               </a:rPr>
-              <a:t>Initial Test Cases</a:t>
+              <a:t>Weekly replenishment</a:t>
             </a:r>
           </a:p>
         </p:txBody>
@@ -31295,7 +31423,7 @@
                 <a:ea typeface="Times New Roman"/>
                 <a:cs typeface="Times New Roman"/>
               </a:rPr>
-              <a:t>2  Design</a:t>
+              <a:t>2  In Progress · WIP 3</a:t>
             </a:r>
           </a:p>
         </p:txBody>
@@ -31366,7 +31494,7 @@
                 <a:ea typeface="Times New Roman"/>
                 <a:cs typeface="Times New Roman"/>
               </a:rPr>
-              <a:t>Sequence &amp; Activity Diagrams</a:t>
+              <a:t>Model storming: Sequence, Activity, ERD</a:t>
             </a:r>
           </a:p>
           <a:p>
@@ -31392,7 +31520,7 @@
                 <a:ea typeface="Times New Roman"/>
                 <a:cs typeface="Times New Roman"/>
               </a:rPr>
-              <a:t>Class Diagram + ERD update</a:t>
+              <a:t>One branch per item</a:t>
             </a:r>
           </a:p>
           <a:p>
@@ -31418,7 +31546,7 @@
                 <a:ea typeface="Times New Roman"/>
                 <a:cs typeface="Times New Roman"/>
               </a:rPr>
-              <a:t>UI Screen Design</a:t>
+              <a:t>Code + unit tests</a:t>
             </a:r>
           </a:p>
         </p:txBody>
@@ -31543,7 +31671,7 @@
                 <a:ea typeface="Times New Roman"/>
                 <a:cs typeface="Times New Roman"/>
               </a:rPr>
-              <a:t>3  Implementation</a:t>
+              <a:t>3  Review · WIP 2</a:t>
             </a:r>
           </a:p>
         </p:txBody>
@@ -31614,7 +31742,7 @@
                 <a:ea typeface="Times New Roman"/>
                 <a:cs typeface="Times New Roman"/>
               </a:rPr>
-              <a:t>Feature branch per User Story</a:t>
+              <a:t>Pull Request + CI</a:t>
             </a:r>
           </a:p>
           <a:p>
@@ -31640,7 +31768,7 @@
                 <a:ea typeface="Times New Roman"/>
                 <a:cs typeface="Times New Roman"/>
               </a:rPr>
-              <a:t>Unit tests with the code</a:t>
+              <a:t>Reviewed by another member</a:t>
             </a:r>
           </a:p>
           <a:p>
@@ -31666,7 +31794,7 @@
                 <a:ea typeface="Times New Roman"/>
                 <a:cs typeface="Times New Roman"/>
               </a:rPr>
-              <a:t>Pull Request + CI</a:t>
+              <a:t>Integration tests</a:t>
             </a:r>
           </a:p>
         </p:txBody>
@@ -31791,7 +31919,7 @@
                 <a:ea typeface="Times New Roman"/>
                 <a:cs typeface="Times New Roman"/>
               </a:rPr>
-              <a:t>4  Testing &amp; Review</a:t>
+              <a:t>4  Done → Released</a:t>
             </a:r>
           </a:p>
         </p:txBody>
@@ -31862,7 +31990,7 @@
                 <a:ea typeface="Times New Roman"/>
                 <a:cs typeface="Times New Roman"/>
               </a:rPr>
-              <a:t>Integration &amp; System Tests</a:t>
+              <a:t>Merged into develop</a:t>
             </a:r>
           </a:p>
           <a:p>
@@ -31888,7 +32016,7 @@
                 <a:ea typeface="Times New Roman"/>
                 <a:cs typeface="Times New Roman"/>
               </a:rPr>
-              <a:t>Sprint Review with supervisors</a:t>
+              <a:t>Review with supervisors every 2 weeks</a:t>
             </a:r>
           </a:p>
           <a:p>
@@ -31914,7 +32042,7 @@
                 <a:ea typeface="Times New Roman"/>
                 <a:cs typeface="Times New Roman"/>
               </a:rPr>
-              <a:t>Retrospective + Release Tag</a:t>
+              <a:t>Release tag + workflow review</a:t>
             </a:r>
           </a:p>
         </p:txBody>
@@ -32035,6 +32163,17 @@
               <a:buNone/>
             </a:pPr>
             <a:r>
+              <a:rPr lang="ar-SY" altLang="en-US" sz="1300" b="1" i="0" dirty="0">
+                <a:solidFill>
+                  <a:srgbClr val="1A1A1A"/>
+                </a:solidFill>
+                <a:latin typeface="Times New Roman"/>
+                <a:ea typeface="Times New Roman"/>
+                <a:cs typeface="Times New Roman"/>
+              </a:rPr>
+              <a:t>↻  أربعة </a:t>
+            </a:r>
+            <a:r>
               <a:rPr lang="en-US" altLang="en-US" sz="1300" b="1" i="0" dirty="0">
                 <a:solidFill>
                   <a:srgbClr val="1A1A1A"/>
@@ -32043,7 +32182,7 @@
                 <a:ea typeface="Times New Roman"/>
                 <a:cs typeface="Times New Roman"/>
               </a:rPr>
-              <a:t>↻ </a:t>
+              <a:t>Increments </a:t>
             </a:r>
             <a:r>
               <a:rPr lang="ar-SA" altLang="en-US" sz="1300" b="1" i="0" dirty="0">
@@ -32065,7 +32204,7 @@
                 <a:ea typeface="Times New Roman"/>
                 <a:cs typeface="Times New Roman"/>
               </a:rPr>
-              <a:t>تتكرر هذه الدورة في أربعة</a:t>
+              <a:t>من </a:t>
             </a:r>
             <a:r>
               <a:rPr lang="en-US" altLang="en-US" sz="1300" b="1" i="0" dirty="0">
@@ -32076,7 +32215,7 @@
                 <a:ea typeface="Times New Roman"/>
                 <a:cs typeface="Times New Roman"/>
               </a:rPr>
-              <a:t> Sprints </a:t>
+              <a:t> 2/11 </a:t>
             </a:r>
             <a:r>
               <a:rPr lang="ar-SY" altLang="en-US" sz="1300" b="1" i="0" dirty="0">
@@ -32087,7 +32226,7 @@
                 <a:ea typeface="Times New Roman"/>
                 <a:cs typeface="Times New Roman"/>
               </a:rPr>
-              <a:t>من</a:t>
+              <a:t>حتى </a:t>
             </a:r>
             <a:r>
               <a:rPr lang="en-US" altLang="en-US" sz="1300" b="1" i="0" dirty="0">
@@ -32098,7 +32237,18 @@
                 <a:ea typeface="Times New Roman"/>
                 <a:cs typeface="Times New Roman"/>
               </a:rPr>
-              <a:t> 2/11 </a:t>
+              <a:t>27/12 </a:t>
+            </a:r>
+            <a:r>
+              <a:rPr lang="ar-SA" altLang="en-US" sz="1300" b="1" i="0" dirty="0">
+                <a:solidFill>
+                  <a:srgbClr val="1A1A1A"/>
+                </a:solidFill>
+                <a:latin typeface="Times New Roman"/>
+                <a:ea typeface="Times New Roman"/>
+                <a:cs typeface="Times New Roman"/>
+              </a:rPr>
+              <a:t> </a:t>
             </a:r>
             <a:r>
               <a:rPr lang="ar-SY" altLang="en-US" sz="1300" b="1" i="0" dirty="0">
@@ -32109,7 +32259,7 @@
                 <a:ea typeface="Times New Roman"/>
                 <a:cs typeface="Times New Roman"/>
               </a:rPr>
-              <a:t>حتى</a:t>
+              <a:t>ومراجعة مع المشرفين كل أسبوعين، ثم </a:t>
             </a:r>
             <a:r>
               <a:rPr lang="en-US" altLang="en-US" sz="1300" b="1" i="0" dirty="0">
@@ -32120,29 +32270,7 @@
                 <a:ea typeface="Times New Roman"/>
                 <a:cs typeface="Times New Roman"/>
               </a:rPr>
-              <a:t> 27/12 </a:t>
-            </a:r>
-            <a:r>
-              <a:rPr lang="ar-SY" altLang="en-US" sz="1300" b="1" i="0" dirty="0">
-                <a:solidFill>
-                  <a:srgbClr val="1A1A1A"/>
-                </a:solidFill>
-                <a:latin typeface="Times New Roman"/>
-                <a:ea typeface="Times New Roman"/>
-                <a:cs typeface="Times New Roman"/>
-              </a:rPr>
-              <a:t>، ثم يبدأ </a:t>
-            </a:r>
-            <a:r>
-              <a:rPr lang="en-US" altLang="en-US" sz="1300" b="1" i="0" dirty="0">
-                <a:solidFill>
-                  <a:srgbClr val="1A1A1A"/>
-                </a:solidFill>
-                <a:latin typeface="Times New Roman"/>
-                <a:ea typeface="Times New Roman"/>
-                <a:cs typeface="Times New Roman"/>
-              </a:rPr>
-              <a:t> Feature Freeze</a:t>
+              <a:t>Feature Freeze</a:t>
             </a:r>
             <a:endParaRPr lang="ar-SY" altLang="en-US" sz="1300" b="1" i="0" dirty="0">
               <a:solidFill>
@@ -32215,7 +32343,7 @@
                 <a:ea typeface="Times New Roman"/>
                 <a:cs typeface="Times New Roman"/>
               </a:rPr>
-              <a:t>Release (S5)</a:t>
+              <a:t>Release</a:t>
             </a:r>
             <a:endParaRPr lang="ar-SY" altLang="en-US" sz="1500" b="1" i="0" dirty="0">
               <a:solidFill>
@@ -32489,7 +32617,40 @@
               <a:buNone/>
             </a:pPr>
             <a:r>
-              <a:rPr lang="ar-SA" altLang="en-US" sz="1300" i="0" dirty="0">
+              <a:rPr lang="ar-SY" altLang="en-US" sz="1300" b="1" i="0" dirty="0">
+                <a:solidFill>
+                  <a:srgbClr val="2F5496"/>
+                </a:solidFill>
+                <a:latin typeface="Times New Roman"/>
+                <a:ea typeface="Times New Roman"/>
+                <a:cs typeface="Times New Roman"/>
+              </a:rPr>
+              <a:t>يمان المطر</a:t>
+            </a:r>
+            <a:r>
+              <a:rPr lang="en-US" altLang="en-US" sz="1300" b="1" i="0" dirty="0">
+                <a:solidFill>
+                  <a:srgbClr val="2F5496"/>
+                </a:solidFill>
+                <a:latin typeface="Times New Roman"/>
+                <a:ea typeface="Times New Roman"/>
+                <a:cs typeface="Times New Roman"/>
+              </a:rPr>
+              <a:t>:</a:t>
+            </a:r>
+            <a:r>
+              <a:rPr lang="ar-SA" altLang="en-US" sz="1300" b="1" i="0" dirty="0">
+                <a:solidFill>
+                  <a:srgbClr val="2F5496"/>
+                </a:solidFill>
+                <a:latin typeface="Times New Roman"/>
+                <a:ea typeface="Times New Roman"/>
+                <a:cs typeface="Times New Roman"/>
+              </a:rPr>
+              <a:t> </a:t>
+            </a:r>
+            <a:r>
+              <a:rPr lang="ar-SY" altLang="en-US" sz="1400" b="0" i="0" dirty="0">
                 <a:solidFill>
                   <a:schemeClr val="tx1"/>
                 </a:solidFill>
@@ -32497,10 +32658,10 @@
                 <a:ea typeface="Times New Roman"/>
                 <a:cs typeface="Times New Roman"/>
               </a:rPr>
-              <a:t>يمان المطر</a:t>
-            </a:r>
-            <a:r>
-              <a:rPr lang="en-US" altLang="en-US" sz="1300" i="0" dirty="0">
+              <a:t>ترتيب الـ </a:t>
+            </a:r>
+            <a:r>
+              <a:rPr lang="en-US" altLang="en-US" sz="1400" b="0" i="0" dirty="0">
                 <a:solidFill>
                   <a:schemeClr val="tx1"/>
                 </a:solidFill>
@@ -32508,29 +32669,18 @@
                 <a:ea typeface="Times New Roman"/>
                 <a:cs typeface="Times New Roman"/>
               </a:rPr>
-              <a:t> </a:t>
-            </a:r>
-            <a:r>
-              <a:rPr lang="en-US" altLang="en-US" sz="1300" b="1" i="0" dirty="0">
-                <a:solidFill>
-                  <a:srgbClr val="2F5496"/>
-                </a:solidFill>
-                <a:latin typeface="Times New Roman"/>
-                <a:ea typeface="Times New Roman"/>
-                <a:cs typeface="Times New Roman"/>
-              </a:rPr>
-              <a:t>Product Owner:</a:t>
-            </a:r>
-            <a:r>
-              <a:rPr lang="en-US" altLang="en-US" sz="1300" b="1" dirty="0">
-                <a:solidFill>
-                  <a:srgbClr val="2F5496"/>
-                </a:solidFill>
-                <a:latin typeface="Times New Roman"/>
-                <a:ea typeface="Times New Roman"/>
-                <a:cs typeface="Times New Roman"/>
-              </a:rPr>
-              <a:t> </a:t>
+              <a:t> Backlog </a:t>
+            </a:r>
+            <a:r>
+              <a:rPr lang="ar-SY" altLang="en-US" sz="1400" b="0" i="0" dirty="0">
+                <a:solidFill>
+                  <a:schemeClr val="tx1"/>
+                </a:solidFill>
+                <a:latin typeface="Times New Roman"/>
+                <a:ea typeface="Times New Roman"/>
+                <a:cs typeface="Times New Roman"/>
+              </a:rPr>
+              <a:t>والتواصل مع المشرفين</a:t>
             </a:r>
             <a:endParaRPr lang="ar-SY" altLang="en-US" sz="1300" b="0" i="0" dirty="0">
               <a:solidFill>
@@ -32597,7 +32747,7 @@
               <a:buNone/>
             </a:pPr>
             <a:r>
-              <a:rPr lang="en-US" altLang="en-US" sz="1300" i="0" dirty="0">
+              <a:rPr lang="ar-SY" altLang="en-US" sz="1300" b="1" i="0" dirty="0">
                 <a:solidFill>
                   <a:srgbClr val="2F5496"/>
                 </a:solidFill>
@@ -32605,10 +32755,32 @@
                 <a:ea typeface="Times New Roman"/>
                 <a:cs typeface="Times New Roman"/>
               </a:rPr>
+              <a:t>يوسف الزعبي</a:t>
+            </a:r>
+            <a:r>
+              <a:rPr lang="ar-SA" altLang="en-US" sz="1300" b="1" i="0" dirty="0">
+                <a:solidFill>
+                  <a:srgbClr val="2F5496"/>
+                </a:solidFill>
+                <a:latin typeface="Times New Roman"/>
+                <a:ea typeface="Times New Roman"/>
+                <a:cs typeface="Times New Roman"/>
+              </a:rPr>
               <a:t> </a:t>
             </a:r>
             <a:r>
-              <a:rPr lang="ar-SA" altLang="en-US" sz="1300" i="0" dirty="0">
+              <a:rPr lang="en-US" altLang="en-US" sz="1300" b="1" i="0" dirty="0">
+                <a:solidFill>
+                  <a:srgbClr val="2F5496"/>
+                </a:solidFill>
+                <a:latin typeface="Times New Roman"/>
+                <a:ea typeface="Times New Roman"/>
+                <a:cs typeface="Times New Roman"/>
+              </a:rPr>
+              <a:t> :</a:t>
+            </a:r>
+            <a:r>
+              <a:rPr lang="ar-SY" altLang="en-US" sz="1400" b="0" i="0" dirty="0">
                 <a:solidFill>
                   <a:schemeClr val="tx1"/>
                 </a:solidFill>
@@ -32616,22 +32788,33 @@
                 <a:ea typeface="Times New Roman"/>
                 <a:cs typeface="Times New Roman"/>
               </a:rPr>
-              <a:t>يوسف الزعبي</a:t>
-            </a:r>
-            <a:r>
-              <a:rPr lang="en-US" altLang="en-US" sz="1300" b="1" i="0" dirty="0">
-                <a:solidFill>
-                  <a:srgbClr val="2F5496"/>
-                </a:solidFill>
-                <a:latin typeface="Times New Roman"/>
-                <a:ea typeface="Times New Roman"/>
-                <a:cs typeface="Times New Roman"/>
-              </a:rPr>
-              <a:t>Scrum Master:</a:t>
+              <a:t>اللوحة وحدود </a:t>
+            </a:r>
+            <a:r>
+              <a:rPr lang="en-US" altLang="en-US" sz="1400" b="0" i="0" dirty="0">
+                <a:solidFill>
+                  <a:schemeClr val="tx1"/>
+                </a:solidFill>
+                <a:latin typeface="Times New Roman"/>
+                <a:ea typeface="Times New Roman"/>
+                <a:cs typeface="Times New Roman"/>
+              </a:rPr>
+              <a:t> WIP </a:t>
+            </a:r>
+            <a:r>
+              <a:rPr lang="ar-SY" altLang="en-US" sz="1400" b="0" i="0" dirty="0">
+                <a:solidFill>
+                  <a:schemeClr val="tx1"/>
+                </a:solidFill>
+                <a:latin typeface="Times New Roman"/>
+                <a:ea typeface="Times New Roman"/>
+                <a:cs typeface="Times New Roman"/>
+              </a:rPr>
+              <a:t>ومقاييس التدفق</a:t>
             </a:r>
             <a:endParaRPr lang="ar-SY" altLang="en-US" sz="1300" b="0" i="0" dirty="0">
               <a:solidFill>
-                <a:srgbClr val="1A1A1A"/>
+                <a:schemeClr val="tx1"/>
               </a:solidFill>
               <a:latin typeface="Times New Roman"/>
               <a:ea typeface="Times New Roman"/>
@@ -32694,7 +32877,7 @@
               <a:buNone/>
             </a:pPr>
             <a:r>
-              <a:rPr lang="en-US" altLang="en-US" sz="1300" i="0" dirty="0">
+              <a:rPr lang="ar-SY" altLang="en-US" sz="1400" b="1" i="0" dirty="0">
                 <a:solidFill>
                   <a:srgbClr val="2F5496"/>
                 </a:solidFill>
@@ -32702,10 +32885,32 @@
                 <a:ea typeface="Times New Roman"/>
                 <a:cs typeface="Times New Roman"/>
               </a:rPr>
+              <a:t>حسن يحيى</a:t>
+            </a:r>
+            <a:r>
+              <a:rPr lang="en-US" altLang="en-US" sz="1400" b="1" i="0" dirty="0">
+                <a:solidFill>
+                  <a:srgbClr val="2F5496"/>
+                </a:solidFill>
+                <a:latin typeface="Times New Roman"/>
+                <a:ea typeface="Times New Roman"/>
+                <a:cs typeface="Times New Roman"/>
+              </a:rPr>
+              <a:t>: </a:t>
+            </a:r>
+            <a:r>
+              <a:rPr lang="ar-SA" altLang="en-US" sz="1400" b="1" i="0" dirty="0">
+                <a:solidFill>
+                  <a:srgbClr val="2F5496"/>
+                </a:solidFill>
+                <a:latin typeface="Times New Roman"/>
+                <a:ea typeface="Times New Roman"/>
+                <a:cs typeface="Times New Roman"/>
+              </a:rPr>
               <a:t> </a:t>
             </a:r>
             <a:r>
-              <a:rPr lang="ar-SY" altLang="en-US" sz="1300" i="0" dirty="0">
+              <a:rPr lang="ar-SY" altLang="en-US" sz="1400" b="0" i="0" dirty="0">
                 <a:solidFill>
                   <a:schemeClr val="tx1"/>
                 </a:solidFill>
@@ -32713,27 +32918,8 @@
                 <a:ea typeface="Times New Roman"/>
                 <a:cs typeface="Times New Roman"/>
               </a:rPr>
-              <a:t>الطلاب الثلاثة </a:t>
-            </a:r>
-            <a:r>
-              <a:rPr lang="en-US" altLang="en-US" sz="1300" b="1" i="0" dirty="0">
-                <a:solidFill>
-                  <a:srgbClr val="2F5496"/>
-                </a:solidFill>
-                <a:latin typeface="Times New Roman"/>
-                <a:ea typeface="Times New Roman"/>
-                <a:cs typeface="Times New Roman"/>
-              </a:rPr>
-              <a:t>Developers:</a:t>
-            </a:r>
-            <a:endParaRPr lang="ar-SY" altLang="en-US" sz="1300" b="0" i="0" dirty="0">
-              <a:solidFill>
-                <a:srgbClr val="1A1A1A"/>
-              </a:solidFill>
-              <a:latin typeface="Times New Roman"/>
-              <a:ea typeface="Times New Roman"/>
-              <a:cs typeface="Times New Roman"/>
-            </a:endParaRPr>
+              <a:t>بنود الذكاء الاصطناعي وتقييم النموذج</a:t>
+            </a:r>
           </a:p>
         </p:txBody>
       </p:sp>
@@ -32791,7 +32977,7 @@
               <a:buNone/>
             </a:pPr>
             <a:r>
-              <a:rPr lang="en-US" altLang="en-US" sz="1300" b="1" i="0" dirty="0">
+              <a:rPr lang="ar-SY" altLang="en-US" sz="1400" b="1" i="0" dirty="0">
                 <a:solidFill>
                   <a:srgbClr val="2F5496"/>
                 </a:solidFill>
@@ -32799,9 +32985,31 @@
                 <a:ea typeface="Times New Roman"/>
                 <a:cs typeface="Times New Roman"/>
               </a:rPr>
-              <a:t>Stakeholders: </a:t>
-            </a:r>
-            <a:endParaRPr lang="ar-SY" altLang="en-US" sz="1300" b="1" i="0" dirty="0">
+              <a:t>المشرفان</a:t>
+            </a:r>
+            <a:r>
+              <a:rPr lang="en-US" altLang="en-US" sz="1400" b="1" i="0" dirty="0">
+                <a:solidFill>
+                  <a:srgbClr val="2F5496"/>
+                </a:solidFill>
+                <a:latin typeface="Times New Roman"/>
+                <a:ea typeface="Times New Roman"/>
+                <a:cs typeface="Times New Roman"/>
+              </a:rPr>
+              <a:t>(Stakeholders) </a:t>
+            </a:r>
+            <a:r>
+              <a:rPr lang="ar-SA" altLang="en-US" sz="1400" b="1" i="0" dirty="0">
+                <a:solidFill>
+                  <a:srgbClr val="2F5496"/>
+                </a:solidFill>
+                <a:latin typeface="Times New Roman"/>
+                <a:ea typeface="Times New Roman"/>
+                <a:cs typeface="Times New Roman"/>
+              </a:rPr>
+              <a:t> :</a:t>
+            </a:r>
+            <a:endParaRPr lang="ar-SY" altLang="en-US" sz="1400" b="1" i="0" dirty="0">
               <a:solidFill>
                 <a:srgbClr val="2F5496"/>
               </a:solidFill>
@@ -32821,7 +33029,7 @@
               <a:buNone/>
             </a:pPr>
             <a:r>
-              <a:rPr lang="ar-SY" altLang="en-US" sz="1300" b="0" i="0" dirty="0">
+              <a:rPr lang="ar-SY" altLang="en-US" sz="1400" b="0" i="0" dirty="0">
                 <a:solidFill>
                   <a:srgbClr val="1A1A1A"/>
                 </a:solidFill>
@@ -32829,27 +33037,8 @@
                 <a:ea typeface="Times New Roman"/>
                 <a:cs typeface="Times New Roman"/>
               </a:rPr>
-              <a:t>المشرفان في كل</a:t>
-            </a:r>
-            <a:r>
-              <a:rPr lang="en-US" altLang="en-US" sz="1300" b="0" i="0" dirty="0">
-                <a:solidFill>
-                  <a:srgbClr val="1A1A1A"/>
-                </a:solidFill>
-                <a:latin typeface="Times New Roman"/>
-                <a:ea typeface="Times New Roman"/>
-                <a:cs typeface="Times New Roman"/>
-              </a:rPr>
-              <a:t> Sprint Review </a:t>
-            </a:r>
-            <a:endParaRPr lang="ar-SY" altLang="en-US" sz="1300" b="0" i="0" dirty="0">
-              <a:solidFill>
-                <a:srgbClr val="1A1A1A"/>
-              </a:solidFill>
-              <a:latin typeface="Times New Roman"/>
-              <a:ea typeface="Times New Roman"/>
-              <a:cs typeface="Times New Roman"/>
-            </a:endParaRPr>
+              <a:t>مراجعة ما أُنجز كل أسبوعين</a:t>
+            </a:r>
           </a:p>
         </p:txBody>
       </p:sp>
@@ -32917,7 +33106,29 @@
                 <a:ea typeface="Times New Roman"/>
                 <a:cs typeface="Times New Roman"/>
               </a:rPr>
-              <a:t> :Definition of Done </a:t>
+              <a:t>Definition of Done </a:t>
+            </a:r>
+            <a:r>
+              <a:rPr lang="ar-SA" altLang="en-US" sz="1400" b="1" i="0" dirty="0">
+                <a:solidFill>
+                  <a:srgbClr val="2F5496"/>
+                </a:solidFill>
+                <a:latin typeface="Times New Roman"/>
+                <a:ea typeface="Times New Roman"/>
+                <a:cs typeface="Times New Roman"/>
+              </a:rPr>
+              <a:t>:</a:t>
+            </a:r>
+            <a:r>
+              <a:rPr lang="en-US" altLang="en-US" sz="1400" b="1" i="0" dirty="0">
+                <a:solidFill>
+                  <a:srgbClr val="2F5496"/>
+                </a:solidFill>
+                <a:latin typeface="Times New Roman"/>
+                <a:ea typeface="Times New Roman"/>
+                <a:cs typeface="Times New Roman"/>
+              </a:rPr>
+              <a:t> </a:t>
             </a:r>
             <a:r>
               <a:rPr lang="ar-SY" altLang="en-US" sz="1400" b="0" i="0" dirty="0">
@@ -32928,7 +33139,7 @@
                 <a:ea typeface="Times New Roman"/>
                 <a:cs typeface="Times New Roman"/>
               </a:rPr>
-              <a:t>الاختبارات ناجحة في</a:t>
+              <a:t>اختبارات </a:t>
             </a:r>
             <a:r>
               <a:rPr lang="en-US" altLang="en-US" sz="1400" b="0" i="0" dirty="0">
@@ -32939,7 +33150,18 @@
                 <a:ea typeface="Times New Roman"/>
                 <a:cs typeface="Times New Roman"/>
               </a:rPr>
-              <a:t> CI + </a:t>
+              <a:t>CI </a:t>
+            </a:r>
+            <a:r>
+              <a:rPr lang="ar-SA" altLang="en-US" sz="1400" b="0" i="0" dirty="0">
+                <a:solidFill>
+                  <a:srgbClr val="1A1A1A"/>
+                </a:solidFill>
+                <a:latin typeface="Times New Roman"/>
+                <a:ea typeface="Times New Roman"/>
+                <a:cs typeface="Times New Roman"/>
+              </a:rPr>
+              <a:t> </a:t>
             </a:r>
             <a:r>
               <a:rPr lang="ar-SY" altLang="en-US" sz="1400" b="0" i="0" dirty="0">
@@ -32950,7 +33172,7 @@
                 <a:ea typeface="Times New Roman"/>
                 <a:cs typeface="Times New Roman"/>
               </a:rPr>
-              <a:t>المخططات محدّثة + قسم التقرير الخاص بالـ</a:t>
+              <a:t>ناجحة </a:t>
             </a:r>
             <a:r>
               <a:rPr lang="en-US" altLang="en-US" sz="1400" b="0" i="0" dirty="0">
@@ -32961,7 +33183,18 @@
                 <a:ea typeface="Times New Roman"/>
                 <a:cs typeface="Times New Roman"/>
               </a:rPr>
-              <a:t> Sprint </a:t>
+              <a:t>+ </a:t>
+            </a:r>
+            <a:r>
+              <a:rPr lang="ar-SA" altLang="en-US" sz="1400" b="0" i="0" dirty="0">
+                <a:solidFill>
+                  <a:srgbClr val="1A1A1A"/>
+                </a:solidFill>
+                <a:latin typeface="Times New Roman"/>
+                <a:ea typeface="Times New Roman"/>
+                <a:cs typeface="Times New Roman"/>
+              </a:rPr>
+              <a:t> </a:t>
             </a:r>
             <a:r>
               <a:rPr lang="ar-SY" altLang="en-US" sz="1400" b="0" i="0" dirty="0">
@@ -32972,8 +33205,93 @@
                 <a:ea typeface="Times New Roman"/>
                 <a:cs typeface="Times New Roman"/>
               </a:rPr>
-              <a:t>مكتوب</a:t>
-            </a:r>
+              <a:t>مراجعة عضو آخر </a:t>
+            </a:r>
+            <a:r>
+              <a:rPr lang="en-US" altLang="en-US" sz="1400" b="0" i="0" dirty="0">
+                <a:solidFill>
+                  <a:srgbClr val="1A1A1A"/>
+                </a:solidFill>
+                <a:latin typeface="Times New Roman"/>
+                <a:ea typeface="Times New Roman"/>
+                <a:cs typeface="Times New Roman"/>
+              </a:rPr>
+              <a:t>+ </a:t>
+            </a:r>
+            <a:r>
+              <a:rPr lang="ar-SA" altLang="en-US" sz="1400" b="0" i="0" dirty="0">
+                <a:solidFill>
+                  <a:srgbClr val="1A1A1A"/>
+                </a:solidFill>
+                <a:latin typeface="Times New Roman"/>
+                <a:ea typeface="Times New Roman"/>
+                <a:cs typeface="Times New Roman"/>
+              </a:rPr>
+              <a:t> </a:t>
+            </a:r>
+            <a:r>
+              <a:rPr lang="ar-SY" altLang="en-US" sz="1400" b="0" i="0" dirty="0">
+                <a:solidFill>
+                  <a:srgbClr val="1A1A1A"/>
+                </a:solidFill>
+                <a:latin typeface="Times New Roman"/>
+                <a:ea typeface="Times New Roman"/>
+                <a:cs typeface="Times New Roman"/>
+              </a:rPr>
+              <a:t>مخططات وتقرير محدّثة</a:t>
+            </a:r>
+            <a:r>
+              <a:rPr lang="en-US" altLang="en-US" sz="1400" b="0" i="0" dirty="0">
+                <a:solidFill>
+                  <a:srgbClr val="1A1A1A"/>
+                </a:solidFill>
+                <a:latin typeface="Times New Roman"/>
+                <a:ea typeface="Times New Roman"/>
+                <a:cs typeface="Times New Roman"/>
+              </a:rPr>
+              <a:t> </a:t>
+            </a:r>
+            <a:r>
+              <a:rPr lang="en-US" altLang="en-US" sz="1400" b="1" i="0" dirty="0">
+                <a:solidFill>
+                  <a:srgbClr val="2F5496"/>
+                </a:solidFill>
+                <a:latin typeface="Times New Roman"/>
+                <a:ea typeface="Times New Roman"/>
+                <a:cs typeface="Times New Roman"/>
+              </a:rPr>
+              <a:t>     Flow Metrics: </a:t>
+            </a:r>
+            <a:r>
+              <a:rPr lang="en-US" altLang="en-US" sz="1400" b="0" i="0" dirty="0">
+                <a:solidFill>
+                  <a:srgbClr val="1A1A1A"/>
+                </a:solidFill>
+                <a:latin typeface="Times New Roman"/>
+                <a:ea typeface="Times New Roman"/>
+                <a:cs typeface="Times New Roman"/>
+              </a:rPr>
+              <a:t>WIP · Throughput · Cycle Time · Item Age </a:t>
+            </a:r>
+            <a:r>
+              <a:rPr lang="ar-SA" altLang="en-US" sz="1400" b="0" i="0" dirty="0">
+                <a:solidFill>
+                  <a:srgbClr val="1A1A1A"/>
+                </a:solidFill>
+                <a:latin typeface="Times New Roman"/>
+                <a:ea typeface="Times New Roman"/>
+                <a:cs typeface="Times New Roman"/>
+              </a:rPr>
+              <a:t> </a:t>
+            </a:r>
+            <a:endParaRPr lang="en-US" altLang="en-US" sz="1400" b="0" i="0" dirty="0">
+              <a:solidFill>
+                <a:srgbClr val="1A1A1A"/>
+              </a:solidFill>
+              <a:latin typeface="Times New Roman"/>
+              <a:ea typeface="Times New Roman"/>
+              <a:cs typeface="Times New Roman"/>
+            </a:endParaRPr>
           </a:p>
         </p:txBody>
       </p:sp>
@@ -35005,7 +35323,7 @@
                 <a:ea typeface="Times New Roman"/>
                 <a:cs typeface="Times New Roman"/>
               </a:rPr>
-              <a:t>[22][23]</a:t>
+              <a:t>[22][24]</a:t>
             </a:r>
           </a:p>
           <a:p>
@@ -35042,7 +35360,7 @@
                 <a:ea typeface="Times New Roman"/>
                 <a:cs typeface="Times New Roman"/>
               </a:rPr>
-              <a:t>[24]</a:t>
+              <a:t>[25]</a:t>
             </a:r>
           </a:p>
           <a:p>
@@ -35079,7 +35397,7 @@
                 <a:ea typeface="Times New Roman"/>
                 <a:cs typeface="Times New Roman"/>
               </a:rPr>
-              <a:t>) [25]</a:t>
+              <a:t>) [26]</a:t>
             </a:r>
             <a:endParaRPr lang="en-US" altLang="en-US" sz="1200" b="0" i="0" dirty="0">
               <a:solidFill>
@@ -35142,7 +35460,7 @@
                 <a:ea typeface="Times New Roman"/>
                 <a:cs typeface="Times New Roman"/>
               </a:rPr>
-              <a:t>[23]</a:t>
+              <a:t>[24]</a:t>
             </a:r>
             <a:endParaRPr lang="en-US" altLang="en-US" sz="1200" b="0" i="0" dirty="0">
               <a:solidFill>
@@ -35624,7 +35942,7 @@
                 <a:ea typeface="Times New Roman"/>
                 <a:cs typeface="Times New Roman"/>
               </a:rPr>
-              <a:t>: GitHub Projects (Product Backlog + Sprint Board)</a:t>
+              <a:t>: GitHub Projects (Kanban)</a:t>
             </a:r>
           </a:p>
           <a:p>

</xml_diff>

<commit_message>
A minor edit to the documentation files
</commit_message>
<xml_diff>
--- a/documentation/graduation-1/Smart Survey Platform - Graduation 1 - Seminar 1.pptx
+++ b/documentation/graduation-1/Smart Survey Platform - Graduation 1 - Seminar 1.pptx
@@ -218,7 +218,7 @@
           <a:p>
             <a:fld id="{5A2D380A-B25C-4554-9D12-6A864851EAA3}" type="datetimeFigureOut">
               <a:rPr lang="en-US" smtClean="0"/>
-              <a:t>10/29/2026</a:t>
+              <a:t>10/30/2026</a:t>
             </a:fld>
             <a:endParaRPr lang="en-US"/>
           </a:p>
@@ -1508,7 +1508,7 @@
           <a:p>
             <a:fld id="{4E54A005-A4AE-48B5-9B72-AC59F9D0C9F3}" type="datetime1">
               <a:rPr lang="en-US" smtClean="0"/>
-              <a:t>10/29/2026</a:t>
+              <a:t>10/30/2026</a:t>
             </a:fld>
             <a:endParaRPr lang="en-US"/>
           </a:p>
@@ -1710,7 +1710,7 @@
           <a:p>
             <a:fld id="{07C97074-5979-461C-BB0D-F24AD7AEA7D7}" type="datetime1">
               <a:rPr lang="en-US" smtClean="0"/>
-              <a:t>10/29/2026</a:t>
+              <a:t>10/30/2026</a:t>
             </a:fld>
             <a:endParaRPr lang="en-US"/>
           </a:p>
@@ -1922,7 +1922,7 @@
           <a:p>
             <a:fld id="{CF7CA7B2-F8F1-4C99-9A58-0619E9B4236C}" type="datetime1">
               <a:rPr lang="en-US" smtClean="0"/>
-              <a:t>10/29/2026</a:t>
+              <a:t>10/30/2026</a:t>
             </a:fld>
             <a:endParaRPr lang="en-US"/>
           </a:p>
@@ -2124,7 +2124,7 @@
           <a:p>
             <a:fld id="{CF5F1D80-E922-4C56-BACD-EEFC21DCFF81}" type="datetime1">
               <a:rPr lang="en-US" smtClean="0"/>
-              <a:t>10/29/2026</a:t>
+              <a:t>10/30/2026</a:t>
             </a:fld>
             <a:endParaRPr lang="en-US"/>
           </a:p>
@@ -2403,7 +2403,7 @@
           <a:p>
             <a:fld id="{49343454-2FB9-4C8F-B182-7B2E5743343C}" type="datetime1">
               <a:rPr lang="en-US" smtClean="0"/>
-              <a:t>10/29/2026</a:t>
+              <a:t>10/30/2026</a:t>
             </a:fld>
             <a:endParaRPr lang="en-US"/>
           </a:p>
@@ -2672,7 +2672,7 @@
           <a:p>
             <a:fld id="{5D83650C-01B7-4756-A73F-6F4EA1E5431E}" type="datetime1">
               <a:rPr lang="en-US" smtClean="0"/>
-              <a:t>10/29/2026</a:t>
+              <a:t>10/30/2026</a:t>
             </a:fld>
             <a:endParaRPr lang="en-US"/>
           </a:p>
@@ -3088,7 +3088,7 @@
           <a:p>
             <a:fld id="{733A1D95-9BF9-4CE1-A0EA-90FF297D19D0}" type="datetime1">
               <a:rPr lang="en-US" smtClean="0"/>
-              <a:t>10/29/2026</a:t>
+              <a:t>10/30/2026</a:t>
             </a:fld>
             <a:endParaRPr lang="en-US"/>
           </a:p>
@@ -3233,7 +3233,7 @@
           <a:p>
             <a:fld id="{F9E80EBF-8A8A-40F0-86A7-7286F440E0F3}" type="datetime1">
               <a:rPr lang="en-US" smtClean="0"/>
-              <a:t>10/29/2026</a:t>
+              <a:t>10/30/2026</a:t>
             </a:fld>
             <a:endParaRPr lang="en-US"/>
           </a:p>
@@ -3350,7 +3350,7 @@
           <a:p>
             <a:fld id="{0BEA7337-48F7-4AF7-9A31-C231AA9DABEB}" type="datetime1">
               <a:rPr lang="en-US" smtClean="0"/>
-              <a:t>10/29/2026</a:t>
+              <a:t>10/30/2026</a:t>
             </a:fld>
             <a:endParaRPr lang="en-US"/>
           </a:p>
@@ -3665,7 +3665,7 @@
           <a:p>
             <a:fld id="{F9F60AB9-8616-4B55-B544-8181381708AB}" type="datetime1">
               <a:rPr lang="en-US" smtClean="0"/>
-              <a:t>10/29/2026</a:t>
+              <a:t>10/30/2026</a:t>
             </a:fld>
             <a:endParaRPr lang="en-US"/>
           </a:p>
@@ -3957,7 +3957,7 @@
           <a:p>
             <a:fld id="{E207D518-531C-4414-B657-2CD37CCA6B63}" type="datetime1">
               <a:rPr lang="en-US" smtClean="0"/>
-              <a:t>10/29/2026</a:t>
+              <a:t>10/30/2026</a:t>
             </a:fld>
             <a:endParaRPr lang="en-US"/>
           </a:p>
@@ -4202,7 +4202,7 @@
           <a:p>
             <a:fld id="{5359F99F-ECCB-4E1D-B4DE-BB12197DD00B}" type="datetime1">
               <a:rPr lang="en-US" smtClean="0"/>
-              <a:t>10/29/2026</a:t>
+              <a:t>10/30/2026</a:t>
             </a:fld>
             <a:endParaRPr lang="en-US"/>
           </a:p>
@@ -5159,7 +5159,7 @@
                 <a:ea typeface="Times New Roman"/>
                 <a:cs typeface="Times New Roman"/>
               </a:rPr>
-              <a:t>م. شادي بليدي          م. محمد عامر خورشيد</a:t>
+              <a:t>م. شادي بليدي          </a:t>
             </a:r>
           </a:p>
           <a:p>

</xml_diff>